<commit_message>
docs(v1.7.37): full unit test report, UI screenshots, testing diagram, TH decks
- npm run test:unit:report: 2645 tests, UNIT_TEST_UI_COVERAGE.md with gate PNGs
- html-diagrams/17-testing-quality-gate (mermaid + embedded screenshots)
- Update Presentations README, TECHNICAL_DOCUMENTATION, PRESENTATION_SCRIPT
- Rebuild TECHNICAL_ARCHITECTURE Word/PPT (TH Sarabun 16pt, FC Iconic)

Co-authored-by: Cursor <cursoragent@cursor.com>
</commit_message>
<xml_diff>
--- a/docs/TECHNICAL_ARCHITECTURE_PPT_TH.pptx
+++ b/docs/TECHNICAL_ARCHITECTURE_PPT_TH.pptx
@@ -20,6 +20,7 @@
     <p:sldId id="268" r:id="rId20"/>
     <p:sldId id="269" r:id="rId21"/>
     <p:sldId id="270" r:id="rId22"/>
+    <p:sldId id="271" r:id="rId23"/>
   </p:sldIdLst>
   <p:sldSz cx="12191695" cy="6858000" type="screen4x3"/>
   <p:notesSz cx="6858000" cy="9144000"/>
@@ -922,6 +923,81 @@
 </file>
 
 <file path=ppt/notesSlides/notesSlide15.xml><?xml version="1.0" encoding="utf-8"?>
+<p:notes xmlns:a="http://schemas.openxmlformats.org/drawingml/2006/main" xmlns:p="http://schemas.openxmlformats.org/presentationml/2006/main" xmlns:r="http://schemas.openxmlformats.org/officeDocument/2006/relationships">
+  <p:cSld>
+    <p:spTree>
+      <p:nvGrpSpPr>
+        <p:cNvPr id="1" name=""/>
+        <p:cNvGrpSpPr/>
+        <p:nvPr/>
+      </p:nvGrpSpPr>
+      <p:grpSpPr>
+        <a:xfrm>
+          <a:off x="0" y="0"/>
+          <a:ext cx="0" cy="0"/>
+          <a:chOff x="0" y="0"/>
+          <a:chExt cx="0" cy="0"/>
+        </a:xfrm>
+      </p:grpSpPr>
+      <p:sp>
+        <p:nvSpPr>
+          <p:cNvPr id="2" name="Slide Image Placeholder 1"/>
+          <p:cNvSpPr>
+            <a:spLocks noGrp="1"/>
+          </p:cNvSpPr>
+          <p:nvPr>
+            <p:ph type="sldImg" idx="2"/>
+          </p:nvPr>
+        </p:nvSpPr>
+        <p:spPr/>
+      </p:sp>
+      <p:sp>
+        <p:nvSpPr>
+          <p:cNvPr id="3" name="Notes Placeholder 2"/>
+          <p:cNvSpPr>
+            <a:spLocks noGrp="1"/>
+          </p:cNvSpPr>
+          <p:nvPr>
+            <p:ph type="body" idx="3" sz="quarter"/>
+          </p:nvPr>
+        </p:nvSpPr>
+        <p:spPr/>
+        <p:txBody>
+          <a:bodyPr/>
+          <a:lstStyle/>
+          <a:p>
+            <a:pPr>
+              <a:defRPr sz="1600" b="0">
+                <a:latin typeface="FC Iconic"/>
+              </a:defRPr>
+            </a:pPr>
+            <a:r>
+              <a:t>npm run test:unit:report และ test:gate:ui-showup</a:t>
+            </a:r>
+          </a:p>
+        </p:txBody>
+      </p:sp>
+      <p:sp>
+        <p:nvSpPr>
+          <p:cNvPr id="4" name="Slide Number Placeholder 3"/>
+          <p:cNvSpPr>
+            <a:spLocks noGrp="1"/>
+          </p:cNvSpPr>
+          <p:nvPr>
+            <p:ph type="sldNum" idx="5" sz="quarter"/>
+          </p:nvPr>
+        </p:nvSpPr>
+        <p:spPr/>
+      </p:sp>
+    </p:spTree>
+  </p:cSld>
+  <p:clrMapOvr>
+    <a:masterClrMapping/>
+  </p:clrMapOvr>
+</p:notes>
+</file>
+
+<file path=ppt/notesSlides/notesSlide16.xml><?xml version="1.0" encoding="utf-8"?>
 <p:notes xmlns:a="http://schemas.openxmlformats.org/drawingml/2006/main" xmlns:p="http://schemas.openxmlformats.org/presentationml/2006/main" xmlns:r="http://schemas.openxmlformats.org/officeDocument/2006/relationships">
   <p:cSld>
     <p:spTree>
@@ -4648,7 +4724,7 @@
               </a:defRPr>
             </a:pPr>
             <a:r>
-              <a:t>• เวอร์ชัน 1.7.33 | จัดทำ 27 พฤษภาคม 2569</a:t>
+              <a:t>• เวอร์ชัน 1.7.37 | จัดทำ 28 พฤษภาคม 2569</a:t>
             </a:r>
           </a:p>
           <a:p>
@@ -5638,6 +5714,445 @@
               </a:defRPr>
             </a:pPr>
             <a:r>
+              <a:t>การทดสอบและคุณภาพ (v1.7.37)</a:t>
+            </a:r>
+          </a:p>
+        </p:txBody>
+      </p:sp>
+      <p:graphicFrame>
+        <p:nvGraphicFramePr>
+          <p:cNvPr id="3" name="Table 2"/>
+          <p:cNvGraphicFramePr>
+            <a:graphicFrameLocks noGrp="1"/>
+          </p:cNvGraphicFramePr>
+          <p:nvPr/>
+        </p:nvGraphicFramePr>
+        <p:xfrm>
+          <a:off x="411480" y="1051560"/>
+          <a:ext cx="11155680" cy="2240279"/>
+        </p:xfrm>
+        <a:graphic>
+          <a:graphicData uri="http://schemas.openxmlformats.org/drawingml/2006/table">
+            <a:tbl>
+              <a:tblPr firstRow="1" bandRow="1">
+                <a:tableStyleId>{5C22544A-7EE6-4342-B048-85BDC9FD1C3A}</a:tableStyleId>
+              </a:tblPr>
+              <a:tblGrid>
+                <a:gridCol w="3718560"/>
+                <a:gridCol w="3718560"/>
+                <a:gridCol w="3718560"/>
+              </a:tblGrid>
+              <a:tr h="373379">
+                <a:tc>
+                  <a:txBody>
+                    <a:bodyPr/>
+                    <a:lstStyle/>
+                    <a:p>
+                      <a:pPr>
+                        <a:defRPr sz="1800" b="1">
+                          <a:latin typeface="FC Iconic"/>
+                        </a:defRPr>
+                      </a:pPr>
+                      <a:r>
+                        <a:t>ชั้น</a:t>
+                      </a:r>
+                    </a:p>
+                  </a:txBody>
+                  <a:tcPr/>
+                </a:tc>
+                <a:tc>
+                  <a:txBody>
+                    <a:bodyPr/>
+                    <a:lstStyle/>
+                    <a:p>
+                      <a:pPr>
+                        <a:defRPr sz="1800" b="1">
+                          <a:latin typeface="FC Iconic"/>
+                        </a:defRPr>
+                      </a:pPr>
+                      <a:r>
+                        <a:t>เครื่องมือ</a:t>
+                      </a:r>
+                    </a:p>
+                  </a:txBody>
+                  <a:tcPr/>
+                </a:tc>
+                <a:tc>
+                  <a:txBody>
+                    <a:bodyPr/>
+                    <a:lstStyle/>
+                    <a:p>
+                      <a:pPr>
+                        <a:defRPr sz="1800" b="1">
+                          <a:latin typeface="FC Iconic"/>
+                        </a:defRPr>
+                      </a:pPr>
+                      <a:r>
+                        <a:t>ผลลัพธ์</a:t>
+                      </a:r>
+                    </a:p>
+                  </a:txBody>
+                  <a:tcPr/>
+                </a:tc>
+              </a:tr>
+              <a:tr h="373379">
+                <a:tc>
+                  <a:txBody>
+                    <a:bodyPr/>
+                    <a:lstStyle/>
+                    <a:p>
+                      <a:pPr>
+                        <a:defRPr sz="1600" b="0">
+                          <a:latin typeface="FC Iconic"/>
+                        </a:defRPr>
+                      </a:pPr>
+                      <a:r>
+                        <a:t>Unit</a:t>
+                      </a:r>
+                    </a:p>
+                  </a:txBody>
+                  <a:tcPr/>
+                </a:tc>
+                <a:tc>
+                  <a:txBody>
+                    <a:bodyPr/>
+                    <a:lstStyle/>
+                    <a:p>
+                      <a:pPr>
+                        <a:defRPr sz="1600" b="0">
+                          <a:latin typeface="FC Iconic"/>
+                        </a:defRPr>
+                      </a:pPr>
+                      <a:r>
+                        <a:t>Vitest 114 ไฟล์</a:t>
+                      </a:r>
+                    </a:p>
+                  </a:txBody>
+                  <a:tcPr/>
+                </a:tc>
+                <a:tc>
+                  <a:txBody>
+                    <a:bodyPr/>
+                    <a:lstStyle/>
+                    <a:p>
+                      <a:pPr>
+                        <a:defRPr sz="1600" b="0">
+                          <a:latin typeface="FC Iconic"/>
+                        </a:defRPr>
+                      </a:pPr>
+                      <a:r>
+                        <a:t>2645 tests ผ่าน</a:t>
+                      </a:r>
+                    </a:p>
+                  </a:txBody>
+                  <a:tcPr/>
+                </a:tc>
+              </a:tr>
+              <a:tr h="373379">
+                <a:tc>
+                  <a:txBody>
+                    <a:bodyPr/>
+                    <a:lstStyle/>
+                    <a:p>
+                      <a:pPr>
+                        <a:defRPr sz="1600" b="0">
+                          <a:latin typeface="FC Iconic"/>
+                        </a:defRPr>
+                      </a:pPr>
+                      <a:r>
+                        <a:t>Sonar</a:t>
+                      </a:r>
+                    </a:p>
+                  </a:txBody>
+                  <a:tcPr/>
+                </a:tc>
+                <a:tc>
+                  <a:txBody>
+                    <a:bodyPr/>
+                    <a:lstStyle/>
+                    <a:p>
+                      <a:pPr>
+                        <a:defRPr sz="1600" b="0">
+                          <a:latin typeface="FC Iconic"/>
+                        </a:defRPr>
+                      </a:pPr>
+                      <a:r>
+                        <a:t>SonarLint + sonar:lint</a:t>
+                      </a:r>
+                    </a:p>
+                  </a:txBody>
+                  <a:tcPr/>
+                </a:tc>
+                <a:tc>
+                  <a:txBody>
+                    <a:bodyPr/>
+                    <a:lstStyle/>
+                    <a:p>
+                      <a:pPr>
+                        <a:defRPr sz="1600" b="0">
+                          <a:latin typeface="FC Iconic"/>
+                        </a:defRPr>
+                      </a:pPr>
+                      <a:r>
+                        <a:t>server/ รวมใน Sonar sources</a:t>
+                      </a:r>
+                    </a:p>
+                  </a:txBody>
+                  <a:tcPr/>
+                </a:tc>
+              </a:tr>
+              <a:tr h="373379">
+                <a:tc>
+                  <a:txBody>
+                    <a:bodyPr/>
+                    <a:lstStyle/>
+                    <a:p>
+                      <a:pPr>
+                        <a:defRPr sz="1600" b="0">
+                          <a:latin typeface="FC Iconic"/>
+                        </a:defRPr>
+                      </a:pPr>
+                      <a:r>
+                        <a:t>Cloud API</a:t>
+                      </a:r>
+                    </a:p>
+                  </a:txBody>
+                  <a:tcPr/>
+                </a:tc>
+                <a:tc>
+                  <a:txBody>
+                    <a:bodyPr/>
+                    <a:lstStyle/>
+                    <a:p>
+                      <a:pPr>
+                        <a:defRPr sz="1600" b="0">
+                          <a:latin typeface="FC Iconic"/>
+                        </a:defRPr>
+                      </a:pPr>
+                      <a:r>
+                        <a:t>verify:gate0</a:t>
+                      </a:r>
+                    </a:p>
+                  </a:txBody>
+                  <a:tcPr/>
+                </a:tc>
+                <a:tc>
+                  <a:txBody>
+                    <a:bodyPr/>
+                    <a:lstStyle/>
+                    <a:p>
+                      <a:pPr>
+                        <a:defRPr sz="1600" b="0">
+                          <a:latin typeface="FC Iconic"/>
+                        </a:defRPr>
+                      </a:pPr>
+                      <a:r>
+                        <a:t>G1–G5 นัดหมาย</a:t>
+                      </a:r>
+                    </a:p>
+                  </a:txBody>
+                  <a:tcPr/>
+                </a:tc>
+              </a:tr>
+              <a:tr h="373379">
+                <a:tc>
+                  <a:txBody>
+                    <a:bodyPr/>
+                    <a:lstStyle/>
+                    <a:p>
+                      <a:pPr>
+                        <a:defRPr sz="1600" b="0">
+                          <a:latin typeface="FC Iconic"/>
+                        </a:defRPr>
+                      </a:pPr>
+                      <a:r>
+                        <a:t>Cloud UI</a:t>
+                      </a:r>
+                    </a:p>
+                  </a:txBody>
+                  <a:tcPr/>
+                </a:tc>
+                <a:tc>
+                  <a:txBody>
+                    <a:bodyPr/>
+                    <a:lstStyle/>
+                    <a:p>
+                      <a:pPr>
+                        <a:defRPr sz="1600" b="0">
+                          <a:latin typeface="FC Iconic"/>
+                        </a:defRPr>
+                      </a:pPr>
+                      <a:r>
+                        <a:t>Playwright A + 7 viewports</a:t>
+                      </a:r>
+                    </a:p>
+                  </a:txBody>
+                  <a:tcPr/>
+                </a:tc>
+                <a:tc>
+                  <a:txBody>
+                    <a:bodyPr/>
+                    <a:lstStyle/>
+                    <a:p>
+                      <a:pPr>
+                        <a:defRPr sz="1600" b="0">
+                          <a:latin typeface="FC Iconic"/>
+                        </a:defRPr>
+                      </a:pPr>
+                      <a:r>
+                        <a:t>41 tests + screenshots</a:t>
+                      </a:r>
+                    </a:p>
+                  </a:txBody>
+                  <a:tcPr/>
+                </a:tc>
+              </a:tr>
+              <a:tr h="373384">
+                <a:tc>
+                  <a:txBody>
+                    <a:bodyPr/>
+                    <a:lstStyle/>
+                    <a:p>
+                      <a:pPr>
+                        <a:defRPr sz="1600" b="0">
+                          <a:latin typeface="FC Iconic"/>
+                        </a:defRPr>
+                      </a:pPr>
+                      <a:r>
+                        <a:t>เอกสาร</a:t>
+                      </a:r>
+                    </a:p>
+                  </a:txBody>
+                  <a:tcPr/>
+                </a:tc>
+                <a:tc>
+                  <a:txBody>
+                    <a:bodyPr/>
+                    <a:lstStyle/>
+                    <a:p>
+                      <a:pPr>
+                        <a:defRPr sz="1600" b="0">
+                          <a:latin typeface="FC Iconic"/>
+                        </a:defRPr>
+                      </a:pPr>
+                      <a:r>
+                        <a:t>UNIT_TEST_UI_COVERAGE.md</a:t>
+                      </a:r>
+                    </a:p>
+                  </a:txBody>
+                  <a:tcPr/>
+                </a:tc>
+                <a:tc>
+                  <a:txBody>
+                    <a:bodyPr/>
+                    <a:lstStyle/>
+                    <a:p>
+                      <a:pPr>
+                        <a:defRPr sz="1600" b="0">
+                          <a:latin typeface="FC Iconic"/>
+                        </a:defRPr>
+                      </a:pPr>
+                      <a:r>
+                        <a:t>แมป unit → ภาพ UI</a:t>
+                      </a:r>
+                    </a:p>
+                  </a:txBody>
+                  <a:tcPr/>
+                </a:tc>
+              </a:tr>
+            </a:tbl>
+          </a:graphicData>
+        </a:graphic>
+      </p:graphicFrame>
+      <p:sp>
+        <p:nvSpPr>
+          <p:cNvPr id="4" name="TextBox 3"/>
+          <p:cNvSpPr txBox="1"/>
+          <p:nvPr/>
+        </p:nvSpPr>
+        <p:spPr>
+          <a:xfrm>
+            <a:off x="411480" y="3428999"/>
+            <a:ext cx="11155680" cy="3154680"/>
+          </a:xfrm>
+          <a:prstGeom prst="rect">
+            <a:avLst/>
+          </a:prstGeom>
+          <a:noFill/>
+        </p:spPr>
+        <p:txBody>
+          <a:bodyPr wrap="square">
+            <a:spAutoFit/>
+          </a:bodyPr>
+          <a:lstStyle/>
+          <a:p>
+            <a:pPr>
+              <a:defRPr sz="1800" b="0">
+                <a:latin typeface="FC Iconic"/>
+              </a:defRPr>
+            </a:pPr>
+            <a:r>
+              <a:t>• แผนภาพ: Presentations/html-diagrams/17-testing-quality-gate.html</a:t>
+            </a:r>
+          </a:p>
+          <a:p>
+            <a:pPr>
+              <a:defRPr sz="1800" b="0">
+                <a:latin typeface="FC Iconic"/>
+              </a:defRPr>
+            </a:pPr>
+            <a:r>
+              <a:t>• ภาพหน้าจอ: docs/screenshots/group-A, group-S, workflows/*</a:t>
+            </a:r>
+          </a:p>
+        </p:txBody>
+      </p:sp>
+    </p:spTree>
+  </p:cSld>
+  <p:clrMapOvr>
+    <a:masterClrMapping/>
+  </p:clrMapOvr>
+</p:sld>
+</file>
+
+<file path=ppt/slides/slide16.xml><?xml version="1.0" encoding="utf-8"?>
+<p:sld xmlns:a="http://schemas.openxmlformats.org/drawingml/2006/main" xmlns:p="http://schemas.openxmlformats.org/presentationml/2006/main" xmlns:r="http://schemas.openxmlformats.org/officeDocument/2006/relationships">
+  <p:cSld>
+    <p:spTree>
+      <p:nvGrpSpPr>
+        <p:cNvPr id="1" name=""/>
+        <p:cNvGrpSpPr/>
+        <p:nvPr/>
+      </p:nvGrpSpPr>
+      <p:grpSpPr/>
+      <p:sp>
+        <p:nvSpPr>
+          <p:cNvPr id="2" name="TextBox 1"/>
+          <p:cNvSpPr txBox="1"/>
+          <p:nvPr/>
+        </p:nvSpPr>
+        <p:spPr>
+          <a:xfrm>
+            <a:off x="365760" y="182880"/>
+            <a:ext cx="11430000" cy="822960"/>
+          </a:xfrm>
+          <a:prstGeom prst="rect">
+            <a:avLst/>
+          </a:prstGeom>
+          <a:noFill/>
+        </p:spPr>
+        <p:txBody>
+          <a:bodyPr wrap="none">
+            <a:spAutoFit/>
+          </a:bodyPr>
+          <a:lstStyle/>
+          <a:p>
+            <a:pPr>
+              <a:defRPr sz="3200" b="1">
+                <a:latin typeface="FC Iconic"/>
+              </a:defRPr>
+            </a:pPr>
+            <a:r>
               <a:t>การ deploy และเอกสารอ้างอิง</a:t>
             </a:r>
           </a:p>
@@ -5681,7 +6196,7 @@
               </a:defRPr>
             </a:pPr>
             <a:r>
-              <a:t>• Cloud: Isara-doctor-portal/cloudbuild.yaml หรือ scripts/deploy/cloud.ps1</a:t>
+              <a:t>• Cloud: npm run cloud:deploy -- -Tag v1.7.37 + traffic shift</a:t>
             </a:r>
           </a:p>
           <a:p>
@@ -5711,7 +6226,7 @@
               </a:defRPr>
             </a:pPr>
             <a:r>
-              <a:t>• สร้างคู่มือ: python scripts/build-technical-architecture-docs.py</a:t>
+              <a:t>• สร้างคู่มือ: npm run guides:technical (TH Sarabun 16pt, FC Iconic PPT)</a:t>
             </a:r>
           </a:p>
         </p:txBody>

</xml_diff>

<commit_message>
release(v1.7.37): verify quality gates, deploy revs 00138/00113
Align patient/jitsi health to 1.7.37, JitsiMeetingShell safe-area, gate artifacts and cloud traffic docs after full test:quality:gate and UI gates.

Co-authored-by: Cursor <cursoragent@cursor.com>
</commit_message>
<xml_diff>
--- a/docs/TECHNICAL_ARCHITECTURE_PPT_TH.pptx
+++ b/docs/TECHNICAL_ARCHITECTURE_PPT_TH.pptx
@@ -972,7 +972,7 @@
               </a:defRPr>
             </a:pPr>
             <a:r>
-              <a:t>npm run test:unit:report และ test:gate:ui-showup</a:t>
+              <a:t>npm run test:unit:report และ test:gate:ui-showup; หลัง deploy ต้อง shift traffic</a:t>
             </a:r>
           </a:p>
         </p:txBody>
@@ -5841,7 +5841,7 @@
                         </a:defRPr>
                       </a:pPr>
                       <a:r>
-                        <a:t>2645 tests ผ่าน</a:t>
+                        <a:t>2646 tests ผ่าน</a:t>
                       </a:r>
                     </a:p>
                   </a:txBody>
@@ -6103,6 +6103,16 @@
             </a:pPr>
             <a:r>
               <a:t>• ภาพหน้าจอ: docs/screenshots/group-A, group-S, workflows/*</a:t>
+            </a:r>
+          </a:p>
+          <a:p>
+            <a:pPr>
+              <a:defRPr sz="1800" b="0">
+                <a:latin typeface="FC Iconic"/>
+              </a:defRPr>
+            </a:pPr>
+            <a:r>
+              <a:t>• Patient Cloud Run: revision 00112-mrm — PHR timeline PATIENT-DEMO 200 (ไม่มี 500 ใน S03)</a:t>
             </a:r>
           </a:p>
         </p:txBody>
@@ -6196,7 +6206,7 @@
               </a:defRPr>
             </a:pPr>
             <a:r>
-              <a:t>• Cloud: npm run cloud:deploy -- -Tag v1.7.37 + traffic shift</a:t>
+              <a:t>• Cloud: npm run cloud:deploy -- -Tag v1.7.37 + gcloud update-traffic (patient 00112-mrm)</a:t>
             </a:r>
           </a:p>
           <a:p>

</xml_diff>

<commit_message>
release(v1.7.48): defect PDF re-audit, Sonar clinical extract, cloud 85/85 headed
All 23 defects verified; 2736 unit tests, 36 defect-regression and 85 full cloud Playwright PASS. Clinical component extraction (EmrEditorChrome, PrescribingModalChrome, LiveTranscriptionView), user guides and screenshots refreshed.

Co-authored-by: Cursor <cursoragent@cursor.com>
</commit_message>
<xml_diff>
--- a/docs/TECHNICAL_ARCHITECTURE_PPT_TH.pptx
+++ b/docs/TECHNICAL_ARCHITECTURE_PPT_TH.pptx
@@ -21,6 +21,7 @@
     <p:sldId id="269" r:id="rId21"/>
     <p:sldId id="270" r:id="rId22"/>
     <p:sldId id="271" r:id="rId23"/>
+    <p:sldId id="272" r:id="rId24"/>
   </p:sldIdLst>
   <p:sldSz cx="12191695" cy="6858000" type="screen4x3"/>
   <p:notesSz cx="6858000" cy="9144000"/>
@@ -972,7 +973,7 @@
               </a:defRPr>
             </a:pPr>
             <a:r>
-              <a:t>npm run test:unit:report และ test:gate:ui-showup; หลัง deploy ต้อง shift traffic</a:t>
+              <a:t>npm run test:unit; test:quality:gate; test:cloud:unit-gate</a:t>
             </a:r>
           </a:p>
         </p:txBody>
@@ -998,6 +999,81 @@
 </file>
 
 <file path=ppt/notesSlides/notesSlide16.xml><?xml version="1.0" encoding="utf-8"?>
+<p:notes xmlns:a="http://schemas.openxmlformats.org/drawingml/2006/main" xmlns:p="http://schemas.openxmlformats.org/presentationml/2006/main" xmlns:r="http://schemas.openxmlformats.org/officeDocument/2006/relationships">
+  <p:cSld>
+    <p:spTree>
+      <p:nvGrpSpPr>
+        <p:cNvPr id="1" name=""/>
+        <p:cNvGrpSpPr/>
+        <p:nvPr/>
+      </p:nvGrpSpPr>
+      <p:grpSpPr>
+        <a:xfrm>
+          <a:off x="0" y="0"/>
+          <a:ext cx="0" cy="0"/>
+          <a:chOff x="0" y="0"/>
+          <a:chExt cx="0" cy="0"/>
+        </a:xfrm>
+      </p:grpSpPr>
+      <p:sp>
+        <p:nvSpPr>
+          <p:cNvPr id="2" name="Slide Image Placeholder 1"/>
+          <p:cNvSpPr>
+            <a:spLocks noGrp="1"/>
+          </p:cNvSpPr>
+          <p:nvPr>
+            <p:ph type="sldImg" idx="2"/>
+          </p:nvPr>
+        </p:nvSpPr>
+        <p:spPr/>
+      </p:sp>
+      <p:sp>
+        <p:nvSpPr>
+          <p:cNvPr id="3" name="Notes Placeholder 2"/>
+          <p:cNvSpPr>
+            <a:spLocks noGrp="1"/>
+          </p:cNvSpPr>
+          <p:nvPr>
+            <p:ph type="body" idx="3" sz="quarter"/>
+          </p:nvPr>
+        </p:nvSpPr>
+        <p:spPr/>
+        <p:txBody>
+          <a:bodyPr/>
+          <a:lstStyle/>
+          <a:p>
+            <a:pPr>
+              <a:defRPr sz="1600" b="0">
+                <a:latin typeface="FC Iconic"/>
+              </a:defRPr>
+            </a:pPr>
+            <a:r>
+              <a:t>reports/defect-fix/v1.7.45-final.txt; DEFECT_REMEDIATION_DRAWIO_UPDATES §9</a:t>
+            </a:r>
+          </a:p>
+        </p:txBody>
+      </p:sp>
+      <p:sp>
+        <p:nvSpPr>
+          <p:cNvPr id="4" name="Slide Number Placeholder 3"/>
+          <p:cNvSpPr>
+            <a:spLocks noGrp="1"/>
+          </p:cNvSpPr>
+          <p:nvPr>
+            <p:ph type="sldNum" idx="5" sz="quarter"/>
+          </p:nvPr>
+        </p:nvSpPr>
+        <p:spPr/>
+      </p:sp>
+    </p:spTree>
+  </p:cSld>
+  <p:clrMapOvr>
+    <a:masterClrMapping/>
+  </p:clrMapOvr>
+</p:notes>
+</file>
+
+<file path=ppt/notesSlides/notesSlide17.xml><?xml version="1.0" encoding="utf-8"?>
 <p:notes xmlns:a="http://schemas.openxmlformats.org/drawingml/2006/main" xmlns:p="http://schemas.openxmlformats.org/presentationml/2006/main" xmlns:r="http://schemas.openxmlformats.org/officeDocument/2006/relationships">
   <p:cSld>
     <p:spTree>
@@ -4724,7 +4800,7 @@
               </a:defRPr>
             </a:pPr>
             <a:r>
-              <a:t>• เวอร์ชัน 1.7.37 | จัดทำ 28 พฤษภาคม 2569</a:t>
+              <a:t>• เวอร์ชัน 1.7.45 | จัดทำ 30 พฤษภาคม 2569</a:t>
             </a:r>
           </a:p>
           <a:p>
@@ -5714,7 +5790,7 @@
               </a:defRPr>
             </a:pPr>
             <a:r>
-              <a:t>การทดสอบและคุณภาพ (v1.7.37)</a:t>
+              <a:t>การทดสอบและคุณภาพ (v1.7.45)</a:t>
             </a:r>
           </a:p>
         </p:txBody>
@@ -5824,7 +5900,7 @@
                         </a:defRPr>
                       </a:pPr>
                       <a:r>
-                        <a:t>Vitest 114 ไฟล์</a:t>
+                        <a:t>Vitest 150 ไฟล์</a:t>
                       </a:r>
                     </a:p>
                   </a:txBody>
@@ -5841,7 +5917,7 @@
                         </a:defRPr>
                       </a:pPr>
                       <a:r>
-                        <a:t>2646 tests ผ่าน</a:t>
+                        <a:t>2731 tests ผ่าน</a:t>
                       </a:r>
                     </a:p>
                   </a:txBody>
@@ -5877,7 +5953,7 @@
                         </a:defRPr>
                       </a:pPr>
                       <a:r>
-                        <a:t>SonarLint + sonar:lint</a:t>
+                        <a:t>SonarLint + sonar-project.properties</a:t>
                       </a:r>
                     </a:p>
                   </a:txBody>
@@ -5894,7 +5970,7 @@
                         </a:defRPr>
                       </a:pPr>
                       <a:r>
-                        <a:t>server/ รวมใน Sonar sources</a:t>
+                        <a:t>S1874/S6594 แก้แล้ว; S6747 suppress</a:t>
                       </a:r>
                     </a:p>
                   </a:txBody>
@@ -5930,7 +6006,7 @@
                         </a:defRPr>
                       </a:pPr>
                       <a:r>
-                        <a:t>verify:gate0</a:t>
+                        <a:t>test:cloud:unit-gate + GATE0</a:t>
                       </a:r>
                     </a:p>
                   </a:txBody>
@@ -5947,7 +6023,7 @@
                         </a:defRPr>
                       </a:pPr>
                       <a:r>
-                        <a:t>G1–G5 นัดหมาย</a:t>
+                        <a:t>78 cloud unit + G1–G5</a:t>
                       </a:r>
                     </a:p>
                   </a:txBody>
@@ -5966,7 +6042,7 @@
                         </a:defRPr>
                       </a:pPr>
                       <a:r>
-                        <a:t>Cloud UI</a:t>
+                        <a:t>Defect UI</a:t>
                       </a:r>
                     </a:p>
                   </a:txBody>
@@ -5983,7 +6059,7 @@
                         </a:defRPr>
                       </a:pPr>
                       <a:r>
-                        <a:t>Playwright A + 7 viewports</a:t>
+                        <a:t>Playwright Defect-regression</a:t>
                       </a:r>
                     </a:p>
                   </a:txBody>
@@ -6000,7 +6076,7 @@
                         </a:defRPr>
                       </a:pPr>
                       <a:r>
-                        <a:t>41 tests + screenshots</a:t>
+                        <a:t>34 passed, 2 skipped (cloud)</a:t>
                       </a:r>
                     </a:p>
                   </a:txBody>
@@ -6036,7 +6112,7 @@
                         </a:defRPr>
                       </a:pPr>
                       <a:r>
-                        <a:t>UNIT_TEST_UI_COVERAGE.md</a:t>
+                        <a:t>draw.io + DOCX/PPTX/PDF</a:t>
                       </a:r>
                     </a:p>
                   </a:txBody>
@@ -6053,7 +6129,7 @@
                         </a:defRPr>
                       </a:pPr>
                       <a:r>
-                        <a:t>แมป unit → ภาพ UI</a:t>
+                        <a:t>docs/diagrams.drawio — ไม่ใช้ HTML diagram</a:t>
                       </a:r>
                     </a:p>
                   </a:txBody>
@@ -6092,7 +6168,7 @@
               </a:defRPr>
             </a:pPr>
             <a:r>
-              <a:t>• แผนภาพ: Presentations/html-diagrams/17-testing-quality-gate.html</a:t>
+              <a:t>• แผนภาพ: docs/diagrams.drawio (export PNG/PDF จาก draw.io)</a:t>
             </a:r>
           </a:p>
           <a:p>
@@ -6102,7 +6178,7 @@
               </a:defRPr>
             </a:pPr>
             <a:r>
-              <a:t>• ภาพหน้าจอ: docs/screenshots/group-A, group-S, workflows/*</a:t>
+              <a:t>• Defect pack: DN5, DP1, DJ1–DJ2 + v1.7.44 suites</a:t>
             </a:r>
           </a:p>
           <a:p>
@@ -6112,7 +6188,7 @@
               </a:defRPr>
             </a:pPr>
             <a:r>
-              <a:t>• Patient Cloud Run: revision 00112-mrm — PHR timeline PATIENT-DEMO 200 (ไม่มี 500 ใน S03)</a:t>
+              <a:t>• PHR persist, map lang=, health library thumbnail</a:t>
             </a:r>
           </a:p>
         </p:txBody>
@@ -6163,7 +6239,7 @@
               </a:defRPr>
             </a:pPr>
             <a:r>
-              <a:t>การ deploy และเอกสารอ้างอิง</a:t>
+              <a:t>Defect Remediation v1.7.45</a:t>
             </a:r>
           </a:p>
         </p:txBody>
@@ -6196,7 +6272,7 @@
               </a:defRPr>
             </a:pPr>
             <a:r>
-              <a:t>• Local: docker-compose up — Patient :3005 Doctor :3010 Meeting :3020</a:t>
+              <a:t>• 23/23 defects Verified — PDF Defect หมออิสระ</a:t>
             </a:r>
           </a:p>
           <a:p>
@@ -6206,7 +6282,121 @@
               </a:defRPr>
             </a:pPr>
             <a:r>
-              <a:t>• Cloud: npm run cloud:deploy -- -Tag v1.7.37 + gcloud update-traffic (patient 00112-mrm)</a:t>
+              <a:t>• Sonar: emrService Blob URL print (S1874); scheduleCountParity RegExp.exec (S6594)</a:t>
+            </a:r>
+          </a:p>
+          <a:p>
+            <a:pPr>
+              <a:defRPr sz="1800" b="0">
+                <a:latin typeface="FC Iconic"/>
+              </a:defRPr>
+            </a:pPr>
+            <a:r>
+              <a:t>• S6747/S6438: CompleteEMREditor, CompletePrescribing, LiveTranscription — parser false positive</a:t>
+            </a:r>
+          </a:p>
+          <a:p>
+            <a:pPr>
+              <a:defRPr sz="1800" b="0">
+                <a:latin typeface="FC Iconic"/>
+              </a:defRPr>
+            </a:pPr>
+            <a:r>
+              <a:t>• Playwright: DN5 mark-all UI, DP1 PHR re-login, DJ1 map lang, DJ2 thumbnail</a:t>
+            </a:r>
+          </a:p>
+        </p:txBody>
+      </p:sp>
+    </p:spTree>
+  </p:cSld>
+  <p:clrMapOvr>
+    <a:masterClrMapping/>
+  </p:clrMapOvr>
+</p:sld>
+</file>
+
+<file path=ppt/slides/slide17.xml><?xml version="1.0" encoding="utf-8"?>
+<p:sld xmlns:a="http://schemas.openxmlformats.org/drawingml/2006/main" xmlns:p="http://schemas.openxmlformats.org/presentationml/2006/main" xmlns:r="http://schemas.openxmlformats.org/officeDocument/2006/relationships">
+  <p:cSld>
+    <p:spTree>
+      <p:nvGrpSpPr>
+        <p:cNvPr id="1" name=""/>
+        <p:cNvGrpSpPr/>
+        <p:nvPr/>
+      </p:nvGrpSpPr>
+      <p:grpSpPr/>
+      <p:sp>
+        <p:nvSpPr>
+          <p:cNvPr id="2" name="TextBox 1"/>
+          <p:cNvSpPr txBox="1"/>
+          <p:nvPr/>
+        </p:nvSpPr>
+        <p:spPr>
+          <a:xfrm>
+            <a:off x="365760" y="182880"/>
+            <a:ext cx="11430000" cy="822960"/>
+          </a:xfrm>
+          <a:prstGeom prst="rect">
+            <a:avLst/>
+          </a:prstGeom>
+          <a:noFill/>
+        </p:spPr>
+        <p:txBody>
+          <a:bodyPr wrap="none">
+            <a:spAutoFit/>
+          </a:bodyPr>
+          <a:lstStyle/>
+          <a:p>
+            <a:pPr>
+              <a:defRPr sz="3200" b="1">
+                <a:latin typeface="FC Iconic"/>
+              </a:defRPr>
+            </a:pPr>
+            <a:r>
+              <a:t>การ deploy และเอกสารอ้างอิง</a:t>
+            </a:r>
+          </a:p>
+        </p:txBody>
+      </p:sp>
+      <p:sp>
+        <p:nvSpPr>
+          <p:cNvPr id="3" name="TextBox 2"/>
+          <p:cNvSpPr txBox="1"/>
+          <p:nvPr/>
+        </p:nvSpPr>
+        <p:spPr>
+          <a:xfrm>
+            <a:off x="411480" y="1051560"/>
+            <a:ext cx="11155680" cy="5532120"/>
+          </a:xfrm>
+          <a:prstGeom prst="rect">
+            <a:avLst/>
+          </a:prstGeom>
+          <a:noFill/>
+        </p:spPr>
+        <p:txBody>
+          <a:bodyPr wrap="square">
+            <a:spAutoFit/>
+          </a:bodyPr>
+          <a:lstStyle/>
+          <a:p>
+            <a:pPr>
+              <a:defRPr sz="1800" b="0">
+                <a:latin typeface="FC Iconic"/>
+              </a:defRPr>
+            </a:pPr>
+            <a:r>
+              <a:t>• Local: docker-compose up — Patient :3005 Doctor :3010 Meeting :3020</a:t>
+            </a:r>
+          </a:p>
+          <a:p>
+            <a:pPr>
+              <a:defRPr sz="1800" b="0">
+                <a:latin typeface="FC Iconic"/>
+              </a:defRPr>
+            </a:pPr>
+            <a:r>
+              <a:t>• Cloud: npm run cloud:deploy -- -Tag v1.7.45 + gcloud update-traffic</a:t>
             </a:r>
           </a:p>
           <a:p>

</xml_diff>